<commit_message>
Final review fixes: honest privacy, cost and scaling claims; deck for Photism
From the final review of all submission files:
- Privacy wording: FaceFinder keeps no photo library; photos are
  processed temporarily and a resized copy goes to Gemini on Vertex AI
  (app window, /privacy, README, SUBMISSION, deck)
- Cost: cached notes avoid repeating Gemini's image analysis for
  unchanged photos; compute and storage are still charged
- Scaling: job progress must be persisted before more than one instance
- Benchmarks labelled as a synthetic stress test or single observed runs
- No unmeasured claim that Gemini is less accurate at identity matching
- "Detects and matches faces" instead of "finds every face"
- Terms: provided "as is"; Q&A placeholders removed
- Deck: team Photism, clickable links, shorter text, larger screenshots;
  video target 3:00 to 3:15

Co-Authored-By: Claude Opus 5.5 <noreply@anthropic.com>
Claude-Session: https://claude.ai/code/session_01W5j9643QJDbFPzediQUcfL
</commit_message>
<xml_diff>
--- a/docs/deck/FaceFinder_deck.pptx
+++ b/docs/deck/FaceFinder_deck.pptx
@@ -6868,14 +6868,14 @@
             <a:r>
               <a:rPr lang="en-GB" sz="1800">
                 <a:solidFill>
-                  <a:srgbClr val="C01E1E"/>
+                  <a:srgbClr val="1F2540"/>
                 </a:solidFill>
                 <a:latin typeface="Google Sans Flex"/>
                 <a:ea typeface="Google Sans Flex"/>
                 <a:cs typeface="Google Sans Flex"/>
                 <a:sym typeface="Google Sans Flex"/>
               </a:rPr>
-              <a:t> [TEAM NAME]</a:t>
+              <a:t> Photism</a:t>
             </a:r>
           </a:p>
           <a:p>
@@ -7226,8 +7226,8 @@
         </p:blipFill>
         <p:spPr>
           <a:xfrm>
-            <a:off x="411480" y="1280160"/>
-            <a:ext cx="4937760" cy="2825729"/>
+            <a:off x="274320" y="1188720"/>
+            <a:ext cx="5486400" cy="3139699"/>
           </a:xfrm>
           <a:prstGeom prst="rect">
             <a:avLst/>
@@ -7247,8 +7247,8 @@
         </p:nvSpPr>
         <p:spPr>
           <a:xfrm>
-            <a:off x="411480" y="4179041"/>
-            <a:ext cx="4937760" cy="548640"/>
+            <a:off x="274320" y="4383283"/>
+            <a:ext cx="5486400" cy="457200"/>
           </a:xfrm>
           <a:prstGeom prst="rect">
             <a:avLst/>
@@ -7294,8 +7294,8 @@
         </p:blipFill>
         <p:spPr>
           <a:xfrm>
-            <a:off x="5623560" y="1280160"/>
-            <a:ext cx="3108960" cy="1295400"/>
+            <a:off x="5897880" y="1188720"/>
+            <a:ext cx="3017520" cy="1257300"/>
           </a:xfrm>
           <a:prstGeom prst="rect">
             <a:avLst/>
@@ -7323,8 +7323,8 @@
         </p:blipFill>
         <p:spPr>
           <a:xfrm>
-            <a:off x="5623560" y="2788920"/>
-            <a:ext cx="3108960" cy="1209040"/>
+            <a:off x="5897880" y="2606040"/>
+            <a:ext cx="3017520" cy="1173480"/>
           </a:xfrm>
           <a:prstGeom prst="rect">
             <a:avLst/>
@@ -7704,7 +7704,7 @@
                 </a:solidFill>
                 <a:latin typeface="Arial"/>
               </a:rPr>
-              <a:t>faces 18 px wide (the back rows of a class photo) found, using two detection sizes</a:t>
+              <a:t>small-face stress test: 40 faces 18 px wide in a synthetic grid</a:t>
             </a:r>
           </a:p>
         </p:txBody>
@@ -7787,7 +7787,7 @@
                 </a:solidFill>
                 <a:latin typeface="Arial"/>
               </a:rPr>
-              <a:t>~2.6 s</a:t>
+              <a:t>1 min 36 s</a:t>
             </a:r>
           </a:p>
           <a:p>
@@ -7803,7 +7803,7 @@
                 </a:solidFill>
                 <a:latin typeface="Arial"/>
               </a:rPr>
-              <a:t>per photo for a live scan with Gemini notes (37 photos in 1 min 36 s, 4 vCPU)</a:t>
+              <a:t>one observed live run: 37 photos scanned with Gemini notes (4 vCPU)</a:t>
             </a:r>
           </a:p>
         </p:txBody>
@@ -7902,7 +7902,7 @@
                 </a:solidFill>
                 <a:latin typeface="Arial"/>
               </a:rPr>
-              <a:t>to export 54 copies into 3 person folders in Google Drive</a:t>
+              <a:t>one observed live run: 54 copies exported into 3 Drive folders</a:t>
             </a:r>
           </a:p>
         </p:txBody>
@@ -8001,7 +8001,7 @@
                 </a:solidFill>
                 <a:latin typeface="Arial"/>
               </a:rPr>
-              <a:t>to find a person from one selfie once the album is scanned</a:t>
+              <a:t>one observed live run: a person found from one selfie</a:t>
             </a:r>
           </a:p>
         </p:txBody>
@@ -8084,7 +8084,7 @@
                 </a:solidFill>
                 <a:latin typeface="Arial"/>
               </a:rPr>
-              <a:t>~5 s</a:t>
+              <a:t>5.2 s</a:t>
             </a:r>
           </a:p>
           <a:p>
@@ -8100,7 +8100,7 @@
                 </a:solidFill>
                 <a:latin typeface="Arial"/>
               </a:rPr>
-              <a:t>for Stop to end a scan; a rescan makes 0 new Gemini calls</a:t>
+              <a:t>one observed live run: Stop ends a scan</a:t>
             </a:r>
           </a:p>
         </p:txBody>
@@ -8139,7 +8139,7 @@
                 </a:solidFill>
                 <a:latin typeface="Arial"/>
               </a:rPr>
-              <a:t>Measured on the live app by test users on 17–18 October 2026, and by the repository's automatic tests.</a:t>
+              <a:t>Scores and the stress test: the repository's automatic tests. Timings: single observed runs on the live app, 17–18 October 2026.</a:t>
             </a:r>
           </a:p>
         </p:txBody>
@@ -8382,7 +8382,7 @@
                 </a:solidFill>
                 <a:latin typeface="Arial"/>
               </a:rPr>
-              <a:t>Trust today: no photos stored, a plain list of what is kept, public privacy policy, and "Delete this album's data" in the album menu.</a:t>
+              <a:t>Trust today: no photo library kept, a plain list of what is kept, a public privacy policy, and "Delete this album's data".</a:t>
             </a:r>
           </a:p>
         </p:txBody>
@@ -8427,12 +8427,12 @@
           <a:p>
             <a:pPr algn="l" marL="164592" indent="-146304">
               <a:spcAft>
-                <a:spcPts val="600"/>
+                <a:spcPts val="800"/>
               </a:spcAft>
               <a:buChar char="•"/>
             </a:pPr>
             <a:r>
-              <a:rPr sz="1200" b="1">
+              <a:rPr sz="1300" b="1">
                 <a:solidFill>
                   <a:srgbClr val="1F2540"/>
                 </a:solidFill>
@@ -8441,24 +8441,24 @@
               <a:t>Scale: </a:t>
             </a:r>
             <a:r>
-              <a:rPr sz="1200" b="0">
+              <a:rPr sz="1300" b="0">
                 <a:solidFill>
                   <a:srgbClr val="1F2540"/>
                 </a:solidFill>
                 <a:latin typeface="Arial"/>
               </a:rPr>
-              <a:t>move scans and exports to Cloud Run jobs or Cloud Tasks; Firestore already holds all state.</a:t>
+              <a:t>persist job progress in Firestore, then run scans on Cloud Run jobs or Cloud Tasks.</a:t>
             </a:r>
           </a:p>
           <a:p>
             <a:pPr algn="l" marL="164592" indent="-146304">
               <a:spcAft>
-                <a:spcPts val="600"/>
+                <a:spcPts val="800"/>
               </a:spcAft>
               <a:buChar char="•"/>
             </a:pPr>
             <a:r>
-              <a:rPr sz="1200" b="1">
+              <a:rPr sz="1300" b="1">
                 <a:solidFill>
                   <a:srgbClr val="1F2540"/>
                 </a:solidFill>
@@ -8467,91 +8467,65 @@
               <a:t>Guest mode: </a:t>
             </a:r>
             <a:r>
-              <a:rPr sz="1200" b="0">
+              <a:rPr sz="1300" b="0">
                 <a:solidFill>
                   <a:srgbClr val="1F2540"/>
                 </a:solidFill>
                 <a:latin typeface="Arial"/>
               </a:rPr>
-              <a:t>a QR code at the event so each guest finds their own photos.</a:t>
+              <a:t>a QR code at the event; each guest finds their own photos.</a:t>
             </a:r>
           </a:p>
           <a:p>
             <a:pPr algn="l" marL="164592" indent="-146304">
               <a:spcAft>
-                <a:spcPts val="600"/>
+                <a:spcPts val="800"/>
               </a:spcAft>
               <a:buChar char="•"/>
             </a:pPr>
             <a:r>
-              <a:rPr sz="1200" b="1">
+              <a:rPr sz="1300" b="1">
                 <a:solidFill>
                   <a:srgbClr val="1F2540"/>
                 </a:solidFill>
                 <a:latin typeface="Arial"/>
               </a:rPr>
-              <a:t>Commercial release: </a:t>
-            </a:r>
-            <a:r>
-              <a:rPr sz="1200" b="0">
+              <a:t>Commercial use: </a:t>
+            </a:r>
+            <a:r>
+              <a:rPr sz="1300" b="0">
                 <a:solidFill>
                   <a:srgbClr val="1F2540"/>
                 </a:solidFill>
                 <a:latin typeface="Arial"/>
               </a:rPr>
-              <a:t>a commercially licensed face model (the InsightFace model files are for non-commercial use).</a:t>
+              <a:t>a commercially licensed face model.</a:t>
             </a:r>
           </a:p>
           <a:p>
             <a:pPr algn="l" marL="164592" indent="-146304">
               <a:spcAft>
-                <a:spcPts val="600"/>
+                <a:spcPts val="400"/>
               </a:spcAft>
               <a:buChar char="•"/>
             </a:pPr>
             <a:r>
-              <a:rPr sz="1200" b="1">
+              <a:rPr sz="1300" b="1">
                 <a:solidFill>
                   <a:srgbClr val="1F2540"/>
                 </a:solidFill>
                 <a:latin typeface="Arial"/>
               </a:rPr>
-              <a:t>Google verification, </a:t>
-            </a:r>
-            <a:r>
-              <a:rPr sz="1200" b="0">
+              <a:t>Google verification: </a:t>
+            </a:r>
+            <a:r>
+              <a:rPr sz="1300" b="0">
                 <a:solidFill>
                   <a:srgbClr val="1F2540"/>
                 </a:solidFill>
                 <a:latin typeface="Arial"/>
               </a:rPr>
-              <a:t>so the "unverified app" warning goes away.</a:t>
-            </a:r>
-          </a:p>
-          <a:p>
-            <a:pPr algn="l" marL="164592" indent="-146304">
-              <a:spcAft>
-                <a:spcPts val="400"/>
-              </a:spcAft>
-              <a:buChar char="•"/>
-            </a:pPr>
-            <a:r>
-              <a:rPr sz="1200" b="1">
-                <a:solidFill>
-                  <a:srgbClr val="1F2540"/>
-                </a:solidFill>
-                <a:latin typeface="Arial"/>
-              </a:rPr>
-              <a:t>More sources: </a:t>
-            </a:r>
-            <a:r>
-              <a:rPr sz="1200" b="0">
-                <a:solidFill>
-                  <a:srgbClr val="1F2540"/>
-                </a:solidFill>
-                <a:latin typeface="Arial"/>
-              </a:rPr>
-              <a:t>Google Photos shared albums, and video.</a:t>
+              <a:t>no more "unverified app" warning.</a:t>
             </a:r>
           </a:p>
         </p:txBody>
@@ -8786,7 +8760,20 @@
                 <a:cs typeface="Google Sans Flex Medium"/>
                 <a:sym typeface="Google Sans Flex Medium"/>
               </a:rPr>
-              <a:t>: https://github.com/Khunapat/facefinder</a:t>
+              <a:t>: </a:t>
+            </a:r>
+            <a:r>
+              <a:rPr lang="en-GB">
+                <a:solidFill>
+                  <a:srgbClr val="1F2540"/>
+                </a:solidFill>
+                <a:latin typeface="Google Sans Flex Medium"/>
+                <a:ea typeface="Google Sans Flex Medium"/>
+                <a:cs typeface="Google Sans Flex Medium"/>
+                <a:sym typeface="Google Sans Flex Medium"/>
+                <a:hlinkClick r:id="rId5"/>
+              </a:rPr>
+              <a:t>https://github.com/Khunapat/facefinder</a:t>
             </a:r>
           </a:p>
           <a:p>
@@ -8819,14 +8806,26 @@
             <a:r>
               <a:rPr lang="en-GB">
                 <a:solidFill>
-                  <a:srgbClr val="C01E1E"/>
+                  <a:srgbClr val="1F2540"/>
                 </a:solidFill>
                 <a:latin typeface="Google Sans Flex Medium"/>
                 <a:ea typeface="Google Sans Flex Medium"/>
                 <a:cs typeface="Google Sans Flex Medium"/>
                 <a:sym typeface="Google Sans Flex Medium"/>
               </a:rPr>
-              <a:t>: [ADD VIDEO LINK]</a:t>
+              <a:t>: </a:t>
+            </a:r>
+            <a:r>
+              <a:rPr lang="en-GB">
+                <a:solidFill>
+                  <a:srgbClr val="C01E1E"/>
+                </a:solidFill>
+                <a:latin typeface="Google Sans Flex Medium"/>
+                <a:ea typeface="Google Sans Flex Medium"/>
+                <a:cs typeface="Google Sans Flex Medium"/>
+                <a:sym typeface="Google Sans Flex Medium"/>
+              </a:rPr>
+              <a:t>[ADD VIDEO LINK]</a:t>
             </a:r>
           </a:p>
           <a:p>
@@ -8866,7 +8865,20 @@
                 <a:cs typeface="Google Sans Flex Medium"/>
                 <a:sym typeface="Google Sans Flex Medium"/>
               </a:rPr>
-              <a:t>: https://facefinder-508213.web.app</a:t>
+              <a:t>: </a:t>
+            </a:r>
+            <a:r>
+              <a:rPr lang="en-GB">
+                <a:solidFill>
+                  <a:srgbClr val="1F2540"/>
+                </a:solidFill>
+                <a:latin typeface="Google Sans Flex Medium"/>
+                <a:ea typeface="Google Sans Flex Medium"/>
+                <a:cs typeface="Google Sans Flex Medium"/>
+                <a:sym typeface="Google Sans Flex Medium"/>
+                <a:hlinkClick r:id="rId6"/>
+              </a:rPr>
+              <a:t>https://facefinder-508213.web.app</a:t>
             </a:r>
           </a:p>
           <a:p>
@@ -9214,17 +9226,17 @@
           <a:p>
             <a:pPr algn="l">
               <a:spcAft>
-                <a:spcPts val="1000"/>
-              </a:spcAft>
-            </a:pPr>
-            <a:r>
-              <a:rPr sz="1200" b="0">
+                <a:spcPts val="1200"/>
+              </a:spcAft>
+            </a:pPr>
+            <a:r>
+              <a:rPr sz="1300" b="0">
                 <a:solidFill>
                   <a:srgbClr val="1F2540"/>
                 </a:solidFill>
                 <a:latin typeface="Arial"/>
               </a:rPr>
-              <a:t>After a graduation, wedding or company event, the photographer shares one Google Drive folder with hundreds of photos. Finding yourself, or sending each friend their photos, means an hour of scrolling, and the photographer still culls blurry and eyes-closed shots by hand.</a:t>
+              <a:t>After an event, the photographer shares one Google Drive folder with hundreds of photos. Finding yourself, or sending friends their photos, means an hour of scrolling.</a:t>
             </a:r>
           </a:p>
           <a:p>
@@ -9250,13 +9262,13 @@
               </a:spcAft>
             </a:pPr>
             <a:r>
-              <a:rPr sz="1200" b="0">
+              <a:rPr sz="1300" b="0">
                 <a:solidFill>
                   <a:srgbClr val="1F2540"/>
                 </a:solidFill>
                 <a:latin typeface="Arial"/>
               </a:rPr>
-              <a:t>Paste the folder link and FaceFinder scans the album once. A face-recognition model groups every face into people; Gemini on Vertex AI judges each photo and describes it. Anyone can then find a person, keep the best shots, sort by plain-word descriptions, and copy one folder per person into their own Drive. The original album is never changed.</a:t>
+              <a:t>Scan the album once. A face model groups faces into people; Gemini judges and describes each photo. Then find a person, keep the best shots, sort by description, and copy one folder per person into your Drive. The album is never changed.</a:t>
             </a:r>
           </a:p>
         </p:txBody>
@@ -9593,7 +9605,7 @@
                 </a:solidFill>
                 <a:latin typeface="Arial"/>
               </a:rPr>
-              <a:t>Google Photos groups faces only inside one person's own library. Event photos usually live in one shared Drive folder, with no face search and no culling. FaceFinder works on any shared Drive folder, for everyone who can open it, and gives back real Drive folders.</a:t>
+              <a:t>Event photos usually live in one shared Drive folder, with no face search and no culling. FaceFinder works on any shared Drive folder, for everyone who can open it, and gives back real Drive folders.</a:t>
             </a:r>
           </a:p>
         </p:txBody>
@@ -9692,7 +9704,7 @@
                 </a:solidFill>
                 <a:latin typeface="Arial"/>
               </a:rPr>
-              <a:t>One scan per album. Then name a face or upload one selfie to get that person's photos. Gemini suggests Keep, Review or Rejected with a reason for each photo, and sorts the album by a plain-word description. One click copies it all into folders in your Drive.</a:t>
+              <a:t>One scan per album. Name a face or upload a selfie to get that person's photos. Gemini suggests keepers with a reason, and sorts by description. One click copies it all to your Drive.</a:t>
             </a:r>
           </a:p>
         </p:txBody>
@@ -9791,7 +9803,7 @@
                 </a:solidFill>
                 <a:latin typeface="Arial"/>
               </a:rPr>
-              <a:t>Two AIs, each doing what it does best: a face model decides who is in a photo, Gemini decides how good it is and what is in it. Copy-only and privacy-first: no photos stored, data deletable at any time. Works on a phone, nothing to install.</a:t>
+              <a:t>Two AIs, each for its job: a face model decides who; Gemini decides how good and what is in it. Copy-only, no photo library kept, data deletable at any time. Works on a phone.</a:t>
             </a:r>
           </a:p>
         </p:txBody>
@@ -11487,7 +11499,7 @@
                 </a:solidFill>
                 <a:latin typeface="Arial"/>
               </a:rPr>
-              <a:t>InsightFace finds faces; Gemini writes one note per photo</a:t>
+              <a:t>InsightFace detects and matches faces; Gemini writes one note per photo</a:t>
             </a:r>
           </a:p>
         </p:txBody>
@@ -12255,8 +12267,8 @@
         </p:blipFill>
         <p:spPr>
           <a:xfrm>
-            <a:off x="548640" y="1280160"/>
-            <a:ext cx="1531620" cy="3063240"/>
+            <a:off x="411480" y="1234440"/>
+            <a:ext cx="1645920" cy="3291840"/>
           </a:xfrm>
           <a:prstGeom prst="rect">
             <a:avLst/>
@@ -12276,8 +12288,8 @@
         </p:nvSpPr>
         <p:spPr>
           <a:xfrm>
-            <a:off x="274320" y="4389120"/>
-            <a:ext cx="2080260" cy="365760"/>
+            <a:off x="137160" y="4544568"/>
+            <a:ext cx="2194560" cy="365760"/>
           </a:xfrm>
           <a:prstGeom prst="rect">
             <a:avLst/>
@@ -12323,8 +12335,8 @@
         </p:blipFill>
         <p:spPr>
           <a:xfrm>
-            <a:off x="2606040" y="1280160"/>
-            <a:ext cx="1531620" cy="1521801"/>
+            <a:off x="2560320" y="1234440"/>
+            <a:ext cx="1645920" cy="1635369"/>
           </a:xfrm>
           <a:prstGeom prst="rect">
             <a:avLst/>
@@ -12344,8 +12356,8 @@
         </p:nvSpPr>
         <p:spPr>
           <a:xfrm>
-            <a:off x="2331720" y="4389120"/>
-            <a:ext cx="2080260" cy="365760"/>
+            <a:off x="2286000" y="4544568"/>
+            <a:ext cx="2194560" cy="365760"/>
           </a:xfrm>
           <a:prstGeom prst="rect">
             <a:avLst/>
@@ -12391,8 +12403,8 @@
         </p:blipFill>
         <p:spPr>
           <a:xfrm>
-            <a:off x="4663440" y="1280160"/>
-            <a:ext cx="1531620" cy="3063240"/>
+            <a:off x="4709160" y="1234440"/>
+            <a:ext cx="1645920" cy="3291840"/>
           </a:xfrm>
           <a:prstGeom prst="rect">
             <a:avLst/>
@@ -12412,8 +12424,8 @@
         </p:nvSpPr>
         <p:spPr>
           <a:xfrm>
-            <a:off x="4389120" y="4389120"/>
-            <a:ext cx="2080260" cy="365760"/>
+            <a:off x="4434840" y="4544568"/>
+            <a:ext cx="2194560" cy="365760"/>
           </a:xfrm>
           <a:prstGeom prst="rect">
             <a:avLst/>
@@ -13208,7 +13220,7 @@
                 </a:solidFill>
                 <a:latin typeface="Arial"/>
               </a:rPr>
-              <a:t>: photo notes, sorting, folder suggestions, structured JSON</a:t>
+              <a:t>: photo notes, sorting, folder suggestions</a:t>
             </a:r>
           </a:p>
           <a:p>
@@ -13233,7 +13245,7 @@
                 </a:solidFill>
                 <a:latin typeface="Arial"/>
               </a:rPr>
-              <a:t>: face detection and 512-number face matching, ONNX Runtime on CPU</a:t>
+              <a:t>: face detection and matching, on CPU</a:t>
             </a:r>
           </a:p>
           <a:p>
@@ -13258,7 +13270,7 @@
                 </a:solidFill>
                 <a:latin typeface="Arial"/>
               </a:rPr>
-              <a:t>: image handling, burst fingerprints</a:t>
+              <a:t>: images, burst fingerprints</a:t>
             </a:r>
           </a:p>
         </p:txBody>
@@ -13441,7 +13453,7 @@
                 </a:solidFill>
                 <a:latin typeface="Arial"/>
               </a:rPr>
-              <a:t>: 90 Python checks, Playwright browser tests</a:t>
+              <a:t>: 90 Python checks, browser tests</a:t>
             </a:r>
           </a:p>
           <a:p>
@@ -13466,7 +13478,7 @@
                 </a:solidFill>
                 <a:latin typeface="Arial"/>
               </a:rPr>
-              <a:t>: browser testing, demo photos of made-up people</a:t>
+              <a:t>: testing, demo photos of made-up people</a:t>
             </a:r>
           </a:p>
         </p:txBody>
@@ -13686,12 +13698,12 @@
           <a:p>
             <a:pPr algn="l" marL="164592" indent="-146304">
               <a:spcAft>
-                <a:spcPts val="600"/>
+                <a:spcPts val="800"/>
               </a:spcAft>
               <a:buChar char="•"/>
             </a:pPr>
             <a:r>
-              <a:rPr sz="1200" b="1">
+              <a:rPr sz="1300" b="1">
                 <a:solidFill>
                   <a:srgbClr val="1F2540"/>
                 </a:solidFill>
@@ -13700,24 +13712,24 @@
               <a:t>Cloud Run: </a:t>
             </a:r>
             <a:r>
-              <a:rPr sz="1200" b="0">
+              <a:rPr sz="1300" b="0">
                 <a:solidFill>
                   <a:srgbClr val="1F2540"/>
                 </a:solidFill>
                 <a:latin typeface="Arial"/>
               </a:rPr>
-              <a:t>one 4-vCPU instance that scales to zero, so an idle app has no compute cost.</a:t>
+              <a:t>one 4-vCPU instance; it scales to zero when idle.</a:t>
             </a:r>
           </a:p>
           <a:p>
             <a:pPr algn="l" marL="164592" indent="-146304">
               <a:spcAft>
-                <a:spcPts val="600"/>
+                <a:spcPts val="800"/>
               </a:spcAft>
               <a:buChar char="•"/>
             </a:pPr>
             <a:r>
-              <a:rPr sz="1200" b="1">
+              <a:rPr sz="1300" b="1">
                 <a:solidFill>
                   <a:srgbClr val="1F2540"/>
                 </a:solidFill>
@@ -13726,65 +13738,65 @@
               <a:t>Gemini: </a:t>
             </a:r>
             <a:r>
-              <a:rPr sz="1200" b="0">
+              <a:rPr sz="1300" b="0">
                 <a:solidFill>
                   <a:srgbClr val="1F2540"/>
                 </a:solidFill>
                 <a:latin typeface="Arial"/>
               </a:rPr>
-              <a:t>one call per photo, once, on a 768 px copy. Results are cached, so rescans cost nothing. Sort sends text only, 40 photos per call.</a:t>
+              <a:t>one image call per photo. Cached notes avoid repeating it for unchanged photos; Sort sends text only.</a:t>
             </a:r>
           </a:p>
           <a:p>
             <a:pPr algn="l" marL="164592" indent="-146304">
               <a:spcAft>
-                <a:spcPts val="600"/>
+                <a:spcPts val="800"/>
               </a:spcAft>
               <a:buChar char="•"/>
             </a:pPr>
             <a:r>
-              <a:rPr sz="1200" b="1">
+              <a:rPr sz="1300" b="1">
                 <a:solidFill>
                   <a:srgbClr val="1F2540"/>
                 </a:solidFill>
                 <a:latin typeface="Arial"/>
               </a:rPr>
-              <a:t>Free after the scan: </a:t>
-            </a:r>
-            <a:r>
-              <a:rPr sz="1200" b="0">
+              <a:t>After the scan: </a:t>
+            </a:r>
+            <a:r>
+              <a:rPr sz="1300" b="0">
                 <a:solidFill>
                   <a:srgbClr val="1F2540"/>
                 </a:solidFill>
                 <a:latin typeface="Arial"/>
               </a:rPr>
-              <a:t>Find people, Cull and Best 10 reuse the saved notes; face matching runs in our container, with no per-photo fee.</a:t>
+              <a:t>Find people, Cull and Best 10 reuse saved notes, with no new Gemini calls.</a:t>
             </a:r>
           </a:p>
           <a:p>
             <a:pPr algn="l" marL="164592" indent="-146304">
               <a:spcAft>
-                <a:spcPts val="600"/>
+                <a:spcPts val="800"/>
               </a:spcAft>
               <a:buChar char="•"/>
             </a:pPr>
             <a:r>
-              <a:rPr sz="1200" b="1">
+              <a:rPr sz="1300" b="1">
                 <a:solidFill>
                   <a:srgbClr val="1F2540"/>
                 </a:solidFill>
                 <a:latin typeface="Arial"/>
               </a:rPr>
-              <a:t>Firestore and Drive: </a:t>
-            </a:r>
-            <a:r>
-              <a:rPr sz="1200" b="0">
+              <a:t>Still charged: </a:t>
+            </a:r>
+            <a:r>
+              <a:rPr sz="1300" b="0">
                 <a:solidFill>
                   <a:srgbClr val="1F2540"/>
                 </a:solidFill>
                 <a:latin typeface="Arial"/>
               </a:rPr>
-              <a:t>one document per photo; copies are made inside Google, with no download or upload.</a:t>
+              <a:t>compute, Firestore storage and reads, as usual. No measured per-album cost is claimed.</a:t>
             </a:r>
           </a:p>
         </p:txBody>
@@ -13963,7 +13975,7 @@
                 </a:solidFill>
                 <a:latin typeface="Arial"/>
               </a:rPr>
-              <a:t>Gemini calls to rescan</a:t>
+              <a:t>new Gemini image calls to rescan unchanged photos</a:t>
             </a:r>
           </a:p>
         </p:txBody>

</xml_diff>

<commit_message>
Fit the form description under 1,024 characters; final deck
Co-Authored-By: Claude Opus 5.5 <noreply@anthropic.com>
Claude-Session: https://claude.ai/code/session_01W5j9643QJDbFPzediQUcfL
</commit_message>
<xml_diff>
--- a/docs/deck/FaceFinder_deck.pptx
+++ b/docs/deck/FaceFinder_deck.pptx
@@ -7886,7 +7886,7 @@
                 </a:solidFill>
                 <a:latin typeface="Arial"/>
               </a:rPr>
-              <a:t>45 s</a:t>
+              <a:t>28 s</a:t>
             </a:r>
           </a:p>
           <a:p>
@@ -7902,7 +7902,7 @@
                 </a:solidFill>
                 <a:latin typeface="Arial"/>
               </a:rPr>
-              <a:t>one observed live run: 54 copies exported into 3 Drive folders</a:t>
+              <a:t>one observed live run: 31 copies exported into 5 Drive folders</a:t>
             </a:r>
           </a:p>
         </p:txBody>
@@ -7985,7 +7985,7 @@
                 </a:solidFill>
                 <a:latin typeface="Arial"/>
               </a:rPr>
-              <a:t>~1 s</a:t>
+              <a:t>16 s</a:t>
             </a:r>
           </a:p>
           <a:p>
@@ -8001,7 +8001,7 @@
                 </a:solidFill>
                 <a:latin typeface="Arial"/>
               </a:rPr>
-              <a:t>one observed live run: a person found from one selfie</a:t>
+              <a:t>one observed live run: upload a selfie, all 3 of that person's photos found</a:t>
             </a:r>
           </a:p>
         </p:txBody>
@@ -8818,14 +8818,14 @@
             <a:r>
               <a:rPr lang="en-GB">
                 <a:solidFill>
-                  <a:srgbClr val="C01E1E"/>
+                  <a:srgbClr val="1F2540"/>
                 </a:solidFill>
                 <a:latin typeface="Google Sans Flex Medium"/>
                 <a:ea typeface="Google Sans Flex Medium"/>
                 <a:cs typeface="Google Sans Flex Medium"/>
                 <a:sym typeface="Google Sans Flex Medium"/>
               </a:rPr>
-              <a:t>[ADD VIDEO LINK]</a:t>
+              <a:t>In the submission form (YouTube)</a:t>
             </a:r>
           </a:p>
           <a:p>

</xml_diff>

<commit_message>
Deck: add the demo video link
Co-Authored-By: Claude Opus 5.5 <noreply@anthropic.com>
Claude-Session: https://claude.ai/code/session_01W5j9643QJDbFPzediQUcfL
</commit_message>
<xml_diff>
--- a/docs/deck/FaceFinder_deck.pptx
+++ b/docs/deck/FaceFinder_deck.pptx
@@ -8824,8 +8824,9 @@
                 <a:ea typeface="Google Sans Flex Medium"/>
                 <a:cs typeface="Google Sans Flex Medium"/>
                 <a:sym typeface="Google Sans Flex Medium"/>
-              </a:rPr>
-              <a:t>In the submission form (YouTube)</a:t>
+                <a:hlinkClick r:id="rId6"/>
+              </a:rPr>
+              <a:t>https://youtu.be/1NW303-InI0</a:t>
             </a:r>
           </a:p>
           <a:p>
@@ -8876,7 +8877,7 @@
                 <a:ea typeface="Google Sans Flex Medium"/>
                 <a:cs typeface="Google Sans Flex Medium"/>
                 <a:sym typeface="Google Sans Flex Medium"/>
-                <a:hlinkClick r:id="rId6"/>
+                <a:hlinkClick r:id="rId7"/>
               </a:rPr>
               <a:t>https://facefinder-508213.web.app</a:t>
             </a:r>

</xml_diff>